<commit_message>
Plot delle funzioni filtro addestrate
</commit_message>
<xml_diff>
--- a/PileUp_m204_update.pptx
+++ b/PileUp_m204_update.pptx
@@ -16,6 +16,8 @@
     <p:sldId id="264" r:id="rId15"/>
     <p:sldId id="265" r:id="rId16"/>
     <p:sldId id="266" r:id="rId17"/>
+    <p:sldId id="267" r:id="rId18"/>
+    <p:sldId id="268" r:id="rId19"/>
   </p:sldIdLst>
   <p:sldSz cx="12191695" cy="6858000" type="screen4x3"/>
   <p:notesSz cx="6858000" cy="9144000"/>
@@ -3460,7 +3462,7 @@
                 </a:solidFill>
                 <a:latin typeface="Calibri"/>
               </a:rPr>
-              <a:t>     Alberto Zanelli  ·  3 July 2026</a:t>
+              <a:t>     Alberto Zanelli  ·  6 July 2026</a:t>
             </a:r>
           </a:p>
         </p:txBody>
@@ -4294,6 +4296,830 @@
                 <a:latin typeface="Calibri"/>
               </a:rPr>
               <a:t>BI monotonicity: SNR 0.57 → SNR·β 0.96.</a:t>
+            </a:r>
+          </a:p>
+        </p:txBody>
+      </p:sp>
+    </p:spTree>
+  </p:cSld>
+  <p:clrMapOvr>
+    <a:masterClrMapping/>
+  </p:clrMapOvr>
+</p:sld>
+</file>
+
+<file path=ppt/slides/slide12.xml><?xml version="1.0" encoding="utf-8"?>
+<p:sld xmlns:a="http://schemas.openxmlformats.org/drawingml/2006/main" xmlns:p="http://schemas.openxmlformats.org/presentationml/2006/main" xmlns:r="http://schemas.openxmlformats.org/officeDocument/2006/relationships">
+  <p:cSld>
+    <p:spTree>
+      <p:nvGrpSpPr>
+        <p:cNvPr id="1" name=""/>
+        <p:cNvGrpSpPr/>
+        <p:nvPr/>
+      </p:nvGrpSpPr>
+      <p:grpSpPr/>
+      <p:sp>
+        <p:nvSpPr>
+          <p:cNvPr id="2" name="Rectangle 1"/>
+          <p:cNvSpPr/>
+          <p:nvPr/>
+        </p:nvSpPr>
+        <p:spPr>
+          <a:xfrm>
+            <a:off x="0" y="0"/>
+            <a:ext cx="12191695" cy="6858000"/>
+          </a:xfrm>
+          <a:prstGeom prst="rect">
+            <a:avLst/>
+          </a:prstGeom>
+          <a:solidFill>
+            <a:srgbClr val="FFFFFF"/>
+          </a:solidFill>
+          <a:ln>
+            <a:noFill/>
+          </a:ln>
+          <a:effectLst/>
+          <a:effectLst/>
+        </p:spPr>
+        <p:style>
+          <a:lnRef idx="1">
+            <a:schemeClr val="accent1"/>
+          </a:lnRef>
+          <a:fillRef idx="3">
+            <a:schemeClr val="accent1"/>
+          </a:fillRef>
+          <a:effectRef idx="2">
+            <a:schemeClr val="accent1"/>
+          </a:effectRef>
+          <a:fontRef idx="minor">
+            <a:schemeClr val="lt1"/>
+          </a:fontRef>
+        </p:style>
+        <p:txBody>
+          <a:bodyPr rtlCol="0" anchor="ctr"/>
+          <a:lstStyle/>
+          <a:p>
+            <a:pPr algn="ctr"/>
+          </a:p>
+        </p:txBody>
+      </p:sp>
+      <p:sp>
+        <p:nvSpPr>
+          <p:cNvPr id="3" name="TextBox 2"/>
+          <p:cNvSpPr txBox="1"/>
+          <p:nvPr/>
+        </p:nvSpPr>
+        <p:spPr>
+          <a:xfrm>
+            <a:off x="640080" y="457200"/>
+            <a:ext cx="10972800" cy="457200"/>
+          </a:xfrm>
+          <a:prstGeom prst="rect">
+            <a:avLst/>
+          </a:prstGeom>
+          <a:noFill/>
+        </p:spPr>
+        <p:txBody>
+          <a:bodyPr wrap="square" anchor="t" lIns="25400" rIns="25400" tIns="25400" bIns="25400">
+            <a:spAutoFit/>
+          </a:bodyPr>
+          <a:lstStyle/>
+          <a:p>
+            <a:pPr algn="l">
+              <a:spcAft>
+                <a:spcPts val="200"/>
+              </a:spcAft>
+            </a:pPr>
+            <a:r>
+              <a:rPr sz="1400" b="1" i="0">
+                <a:solidFill>
+                  <a:srgbClr val="E8871E"/>
+                </a:solidFill>
+                <a:latin typeface="Calibri"/>
+              </a:rPr>
+              <a:t>PART 3 · A BETTER FILTER</a:t>
+            </a:r>
+          </a:p>
+        </p:txBody>
+      </p:sp>
+      <p:sp>
+        <p:nvSpPr>
+          <p:cNvPr id="4" name="TextBox 3"/>
+          <p:cNvSpPr txBox="1"/>
+          <p:nvPr/>
+        </p:nvSpPr>
+        <p:spPr>
+          <a:xfrm>
+            <a:off x="640080" y="868680"/>
+            <a:ext cx="10972800" cy="822960"/>
+          </a:xfrm>
+          <a:prstGeom prst="rect">
+            <a:avLst/>
+          </a:prstGeom>
+          <a:noFill/>
+        </p:spPr>
+        <p:txBody>
+          <a:bodyPr wrap="square" anchor="t" lIns="25400" rIns="25400" tIns="25400" bIns="25400">
+            <a:spAutoFit/>
+          </a:bodyPr>
+          <a:lstStyle/>
+          <a:p>
+            <a:pPr algn="l">
+              <a:spcAft>
+                <a:spcPts val="200"/>
+              </a:spcAft>
+            </a:pPr>
+            <a:r>
+              <a:rPr sz="3400" b="1" i="0">
+                <a:solidFill>
+                  <a:srgbClr val="14213D"/>
+                </a:solidFill>
+                <a:latin typeface="Cambria"/>
+              </a:rPr>
+              <a:t>A trainable Wiener filter</a:t>
+            </a:r>
+          </a:p>
+        </p:txBody>
+      </p:sp>
+      <p:sp>
+        <p:nvSpPr>
+          <p:cNvPr id="5" name="TextBox 4"/>
+          <p:cNvSpPr txBox="1"/>
+          <p:nvPr/>
+        </p:nvSpPr>
+        <p:spPr>
+          <a:xfrm>
+            <a:off x="640080" y="1600200"/>
+            <a:ext cx="10972800" cy="457200"/>
+          </a:xfrm>
+          <a:prstGeom prst="rect">
+            <a:avLst/>
+          </a:prstGeom>
+          <a:noFill/>
+        </p:spPr>
+        <p:txBody>
+          <a:bodyPr wrap="square" anchor="t" lIns="25400" rIns="25400" tIns="25400" bIns="25400">
+            <a:spAutoFit/>
+          </a:bodyPr>
+          <a:lstStyle/>
+          <a:p>
+            <a:pPr algn="l">
+              <a:spcAft>
+                <a:spcPts val="200"/>
+              </a:spcAft>
+            </a:pPr>
+            <a:r>
+              <a:rPr sz="1500" b="0" i="1">
+                <a:solidFill>
+                  <a:srgbClr val="5A6B7B"/>
+                </a:solidFill>
+                <a:latin typeface="Calibri"/>
+              </a:rPr>
+              <a:t>The optimum filter maximizes amplitude SNR; pile-up instead needs sharp, separable pulses. The Wiener filter deconvolves the pulse shape — a trainable λ sets the balance.</a:t>
+            </a:r>
+          </a:p>
+        </p:txBody>
+      </p:sp>
+      <p:sp>
+        <p:nvSpPr>
+          <p:cNvPr id="6" name="Rounded Rectangle 5"/>
+          <p:cNvSpPr/>
+          <p:nvPr/>
+        </p:nvSpPr>
+        <p:spPr>
+          <a:xfrm>
+            <a:off x="640080" y="2194560"/>
+            <a:ext cx="4343400" cy="3931920"/>
+          </a:xfrm>
+          <a:prstGeom prst="roundRect">
+            <a:avLst>
+              <a:gd name="adj" fmla="val 6000"/>
+            </a:avLst>
+          </a:prstGeom>
+          <a:solidFill>
+            <a:srgbClr val="14213D"/>
+          </a:solidFill>
+          <a:ln>
+            <a:noFill/>
+          </a:ln>
+          <a:effectLst/>
+        </p:spPr>
+        <p:style>
+          <a:lnRef idx="1">
+            <a:schemeClr val="accent1"/>
+          </a:lnRef>
+          <a:fillRef idx="3">
+            <a:schemeClr val="accent1"/>
+          </a:fillRef>
+          <a:effectRef idx="2">
+            <a:schemeClr val="accent1"/>
+          </a:effectRef>
+          <a:fontRef idx="minor">
+            <a:schemeClr val="lt1"/>
+          </a:fontRef>
+        </p:style>
+        <p:txBody>
+          <a:bodyPr rtlCol="0" anchor="ctr"/>
+          <a:lstStyle/>
+          <a:p>
+            <a:pPr algn="ctr"/>
+          </a:p>
+        </p:txBody>
+      </p:sp>
+      <p:sp>
+        <p:nvSpPr>
+          <p:cNvPr id="7" name="TextBox 6"/>
+          <p:cNvSpPr txBox="1"/>
+          <p:nvPr/>
+        </p:nvSpPr>
+        <p:spPr>
+          <a:xfrm>
+            <a:off x="640080" y="2423160"/>
+            <a:ext cx="4343400" cy="457200"/>
+          </a:xfrm>
+          <a:prstGeom prst="rect">
+            <a:avLst/>
+          </a:prstGeom>
+          <a:noFill/>
+        </p:spPr>
+        <p:txBody>
+          <a:bodyPr wrap="square" anchor="t" lIns="25400" rIns="25400" tIns="25400" bIns="25400">
+            <a:spAutoFit/>
+          </a:bodyPr>
+          <a:lstStyle/>
+          <a:p>
+            <a:pPr algn="ctr">
+              <a:spcAft>
+                <a:spcPts val="200"/>
+              </a:spcAft>
+            </a:pPr>
+            <a:r>
+              <a:rPr sz="1200" b="1" i="0">
+                <a:solidFill>
+                  <a:srgbClr val="9FB8D6"/>
+                </a:solidFill>
+                <a:latin typeface="Calibri"/>
+              </a:rPr>
+              <a:t>TRAINABLE WIENER FILTER</a:t>
+            </a:r>
+          </a:p>
+        </p:txBody>
+      </p:sp>
+      <p:pic>
+        <p:nvPicPr>
+          <p:cNvPr id="8" name="Picture 7" descr="w_wiener.png"/>
+          <p:cNvPicPr>
+            <a:picLocks noChangeAspect="1"/>
+          </p:cNvPicPr>
+          <p:nvPr/>
+        </p:nvPicPr>
+        <p:blipFill>
+          <a:blip r:embed="rId2"/>
+          <a:stretch>
+            <a:fillRect/>
+          </a:stretch>
+        </p:blipFill>
+        <p:spPr>
+          <a:xfrm>
+            <a:off x="1234440" y="2971800"/>
+            <a:ext cx="1959713" cy="685800"/>
+          </a:xfrm>
+          <a:prstGeom prst="rect">
+            <a:avLst/>
+          </a:prstGeom>
+        </p:spPr>
+      </p:pic>
+      <p:sp>
+        <p:nvSpPr>
+          <p:cNvPr id="9" name="TextBox 8"/>
+          <p:cNvSpPr txBox="1"/>
+          <p:nvPr/>
+        </p:nvSpPr>
+        <p:spPr>
+          <a:xfrm>
+            <a:off x="914400" y="3977639"/>
+            <a:ext cx="3794760" cy="2011680"/>
+          </a:xfrm>
+          <a:prstGeom prst="rect">
+            <a:avLst/>
+          </a:prstGeom>
+          <a:noFill/>
+        </p:spPr>
+        <p:txBody>
+          <a:bodyPr wrap="square" anchor="t" lIns="25400" rIns="25400" tIns="25400" bIns="25400">
+            <a:spAutoFit/>
+          </a:bodyPr>
+          <a:lstStyle/>
+          <a:p>
+            <a:pPr algn="l">
+              <a:lnSpc>
+                <a:spcPct val="115000"/>
+              </a:lnSpc>
+              <a:spcAft>
+                <a:spcPts val="200"/>
+              </a:spcAft>
+            </a:pPr>
+            <a:r>
+              <a:rPr sz="1500" b="1" i="0">
+                <a:solidFill>
+                  <a:srgbClr val="E8871E"/>
+                </a:solidFill>
+                <a:latin typeface="Calibri"/>
+              </a:rPr>
+              <a:t>λ → 0 </a:t>
+            </a:r>
+            <a:r>
+              <a:rPr sz="1400" b="0" i="0">
+                <a:solidFill>
+                  <a:srgbClr val="E8EEF8"/>
+                </a:solidFill>
+                <a:latin typeface="Calibri"/>
+              </a:rPr>
+              <a:t> deconvolution: sharpen the edges, separate close pulses.</a:t>
+            </a:r>
+          </a:p>
+          <a:p>
+            <a:pPr algn="l">
+              <a:lnSpc>
+                <a:spcPct val="115000"/>
+              </a:lnSpc>
+              <a:spcBef>
+                <a:spcPts val="800"/>
+              </a:spcBef>
+              <a:spcAft>
+                <a:spcPts val="200"/>
+              </a:spcAft>
+            </a:pPr>
+            <a:r>
+              <a:rPr sz="1500" b="1" i="0">
+                <a:solidFill>
+                  <a:srgbClr val="E8871E"/>
+                </a:solidFill>
+                <a:latin typeface="Calibri"/>
+              </a:rPr>
+              <a:t>λ → ∞ </a:t>
+            </a:r>
+            <a:r>
+              <a:rPr sz="1400" b="0" i="0">
+                <a:solidFill>
+                  <a:srgbClr val="E8EEF8"/>
+                </a:solidFill>
+                <a:latin typeface="Calibri"/>
+              </a:rPr>
+              <a:t> recovers the optimum filter.</a:t>
+            </a:r>
+          </a:p>
+          <a:p>
+            <a:pPr algn="l">
+              <a:lnSpc>
+                <a:spcPct val="115000"/>
+              </a:lnSpc>
+              <a:spcBef>
+                <a:spcPts val="800"/>
+              </a:spcBef>
+              <a:spcAft>
+                <a:spcPts val="200"/>
+              </a:spcAft>
+            </a:pPr>
+            <a:r>
+              <a:rPr sz="1500" b="1" i="0">
+                <a:solidFill>
+                  <a:srgbClr val="E8871E"/>
+                </a:solidFill>
+                <a:latin typeface="Calibri"/>
+              </a:rPr>
+              <a:t>λ </a:t>
+            </a:r>
+            <a:r>
+              <a:rPr sz="1400" b="0" i="0">
+                <a:solidFill>
+                  <a:srgbClr val="E8EEF8"/>
+                </a:solidFill>
+                <a:latin typeface="Calibri"/>
+              </a:rPr>
+              <a:t> is trained jointly with the band filters f₁, f₂ to minimize the same BI metric J.</a:t>
+            </a:r>
+          </a:p>
+        </p:txBody>
+      </p:sp>
+      <p:pic>
+        <p:nvPicPr>
+          <p:cNvPr id="10" name="Picture 9" descr="lambda_vs_Vbias_m205_wiener.png"/>
+          <p:cNvPicPr>
+            <a:picLocks noChangeAspect="1"/>
+          </p:cNvPicPr>
+          <p:nvPr/>
+        </p:nvPicPr>
+        <p:blipFill>
+          <a:blip r:embed="rId3"/>
+          <a:stretch>
+            <a:fillRect/>
+          </a:stretch>
+        </p:blipFill>
+        <p:spPr>
+          <a:xfrm>
+            <a:off x="6057900" y="2148840"/>
+            <a:ext cx="4800600" cy="3200400"/>
+          </a:xfrm>
+          <a:prstGeom prst="rect">
+            <a:avLst/>
+          </a:prstGeom>
+        </p:spPr>
+      </p:pic>
+      <p:sp>
+        <p:nvSpPr>
+          <p:cNvPr id="11" name="TextBox 10"/>
+          <p:cNvSpPr txBox="1"/>
+          <p:nvPr/>
+        </p:nvSpPr>
+        <p:spPr>
+          <a:xfrm>
+            <a:off x="5212080" y="5440680"/>
+            <a:ext cx="6492240" cy="1188720"/>
+          </a:xfrm>
+          <a:prstGeom prst="rect">
+            <a:avLst/>
+          </a:prstGeom>
+          <a:noFill/>
+        </p:spPr>
+        <p:txBody>
+          <a:bodyPr wrap="square" anchor="t" lIns="25400" rIns="25400" tIns="25400" bIns="25400">
+            <a:spAutoFit/>
+          </a:bodyPr>
+          <a:lstStyle/>
+          <a:p>
+            <a:pPr algn="l">
+              <a:lnSpc>
+                <a:spcPct val="115000"/>
+              </a:lnSpc>
+              <a:spcAft>
+                <a:spcPts val="200"/>
+              </a:spcAft>
+            </a:pPr>
+            <a:r>
+              <a:rPr sz="1400" b="1" i="0">
+                <a:solidFill>
+                  <a:srgbClr val="14213D"/>
+                </a:solidFill>
+                <a:latin typeface="Calibri"/>
+              </a:rPr>
+              <a:t>λ is learned per channel and working point — not fixed. </a:t>
+            </a:r>
+            <a:r>
+              <a:rPr sz="1400" b="0" i="0">
+                <a:solidFill>
+                  <a:srgbClr val="1A2332"/>
+                </a:solidFill>
+                <a:latin typeface="Calibri"/>
+              </a:rPr>
+              <a:t>It spans ~10⁻⁵ (ch91, deconvolution-dominated) to ~10² (ch31, near optimum filter): each detector picks its own noise-vs-deconvolution balance.</a:t>
+            </a:r>
+          </a:p>
+        </p:txBody>
+      </p:sp>
+    </p:spTree>
+  </p:cSld>
+  <p:clrMapOvr>
+    <a:masterClrMapping/>
+  </p:clrMapOvr>
+</p:sld>
+</file>
+
+<file path=ppt/slides/slide13.xml><?xml version="1.0" encoding="utf-8"?>
+<p:sld xmlns:a="http://schemas.openxmlformats.org/drawingml/2006/main" xmlns:p="http://schemas.openxmlformats.org/presentationml/2006/main" xmlns:r="http://schemas.openxmlformats.org/officeDocument/2006/relationships">
+  <p:cSld>
+    <p:spTree>
+      <p:nvGrpSpPr>
+        <p:cNvPr id="1" name=""/>
+        <p:cNvGrpSpPr/>
+        <p:nvPr/>
+      </p:nvGrpSpPr>
+      <p:grpSpPr/>
+      <p:sp>
+        <p:nvSpPr>
+          <p:cNvPr id="2" name="Rectangle 1"/>
+          <p:cNvSpPr/>
+          <p:nvPr/>
+        </p:nvSpPr>
+        <p:spPr>
+          <a:xfrm>
+            <a:off x="0" y="0"/>
+            <a:ext cx="12191695" cy="6858000"/>
+          </a:xfrm>
+          <a:prstGeom prst="rect">
+            <a:avLst/>
+          </a:prstGeom>
+          <a:solidFill>
+            <a:srgbClr val="FFFFFF"/>
+          </a:solidFill>
+          <a:ln>
+            <a:noFill/>
+          </a:ln>
+          <a:effectLst/>
+          <a:effectLst/>
+        </p:spPr>
+        <p:style>
+          <a:lnRef idx="1">
+            <a:schemeClr val="accent1"/>
+          </a:lnRef>
+          <a:fillRef idx="3">
+            <a:schemeClr val="accent1"/>
+          </a:fillRef>
+          <a:effectRef idx="2">
+            <a:schemeClr val="accent1"/>
+          </a:effectRef>
+          <a:fontRef idx="minor">
+            <a:schemeClr val="lt1"/>
+          </a:fontRef>
+        </p:style>
+        <p:txBody>
+          <a:bodyPr rtlCol="0" anchor="ctr"/>
+          <a:lstStyle/>
+          <a:p>
+            <a:pPr algn="ctr"/>
+          </a:p>
+        </p:txBody>
+      </p:sp>
+      <p:sp>
+        <p:nvSpPr>
+          <p:cNvPr id="3" name="TextBox 2"/>
+          <p:cNvSpPr txBox="1"/>
+          <p:nvPr/>
+        </p:nvSpPr>
+        <p:spPr>
+          <a:xfrm>
+            <a:off x="640080" y="457200"/>
+            <a:ext cx="10972800" cy="822960"/>
+          </a:xfrm>
+          <a:prstGeom prst="rect">
+            <a:avLst/>
+          </a:prstGeom>
+          <a:noFill/>
+        </p:spPr>
+        <p:txBody>
+          <a:bodyPr wrap="square" anchor="t" lIns="25400" rIns="25400" tIns="25400" bIns="25400">
+            <a:spAutoFit/>
+          </a:bodyPr>
+          <a:lstStyle/>
+          <a:p>
+            <a:pPr algn="l">
+              <a:spcAft>
+                <a:spcPts val="200"/>
+              </a:spcAft>
+            </a:pPr>
+            <a:r>
+              <a:rPr sz="3000" b="1" i="0">
+                <a:solidFill>
+                  <a:srgbClr val="14213D"/>
+                </a:solidFill>
+                <a:latin typeface="Cambria"/>
+              </a:rPr>
+              <a:t>Wiener vs optimum: the BI drops on every channel</a:t>
+            </a:r>
+          </a:p>
+        </p:txBody>
+      </p:sp>
+      <p:sp>
+        <p:nvSpPr>
+          <p:cNvPr id="4" name="TextBox 3"/>
+          <p:cNvSpPr txBox="1"/>
+          <p:nvPr/>
+        </p:nvSpPr>
+        <p:spPr>
+          <a:xfrm>
+            <a:off x="640080" y="1133856"/>
+            <a:ext cx="10972800" cy="457200"/>
+          </a:xfrm>
+          <a:prstGeom prst="rect">
+            <a:avLst/>
+          </a:prstGeom>
+          <a:noFill/>
+        </p:spPr>
+        <p:txBody>
+          <a:bodyPr wrap="square" anchor="t" lIns="25400" rIns="25400" tIns="25400" bIns="25400">
+            <a:spAutoFit/>
+          </a:bodyPr>
+          <a:lstStyle/>
+          <a:p>
+            <a:pPr algn="l">
+              <a:spcAft>
+                <a:spcPts val="200"/>
+              </a:spcAft>
+            </a:pPr>
+            <a:r>
+              <a:rPr sz="1500" b="0" i="1">
+                <a:solidFill>
+                  <a:srgbClr val="5A6B7B"/>
+                </a:solidFill>
+                <a:latin typeface="Calibri"/>
+              </a:rPr>
+              <a:t>Same estimator, same working points — only the filter changes. Improvement = percentage decrease of the BI.</a:t>
+            </a:r>
+          </a:p>
+        </p:txBody>
+      </p:sp>
+      <p:pic>
+        <p:nvPicPr>
+          <p:cNvPr id="5" name="Picture 4" descr="BI_improvement_vs_Vbias_m205.png"/>
+          <p:cNvPicPr>
+            <a:picLocks noChangeAspect="1"/>
+          </p:cNvPicPr>
+          <p:nvPr/>
+        </p:nvPicPr>
+        <p:blipFill>
+          <a:blip r:embed="rId2"/>
+          <a:stretch>
+            <a:fillRect/>
+          </a:stretch>
+        </p:blipFill>
+        <p:spPr>
+          <a:xfrm>
+            <a:off x="765810" y="1691640"/>
+            <a:ext cx="5280660" cy="3520440"/>
+          </a:xfrm>
+          <a:prstGeom prst="rect">
+            <a:avLst/>
+          </a:prstGeom>
+        </p:spPr>
+      </p:pic>
+      <p:pic>
+        <p:nvPicPr>
+          <p:cNvPr id="6" name="Picture 5" descr="BI_improvement_per_channel_m205.png"/>
+          <p:cNvPicPr>
+            <a:picLocks noChangeAspect="1"/>
+          </p:cNvPicPr>
+          <p:nvPr/>
+        </p:nvPicPr>
+        <p:blipFill>
+          <a:blip r:embed="rId3"/>
+          <a:stretch>
+            <a:fillRect/>
+          </a:stretch>
+        </p:blipFill>
+        <p:spPr>
+          <a:xfrm>
+            <a:off x="6457950" y="1691640"/>
+            <a:ext cx="5280660" cy="3520440"/>
+          </a:xfrm>
+          <a:prstGeom prst="rect">
+            <a:avLst/>
+          </a:prstGeom>
+        </p:spPr>
+      </p:pic>
+      <p:sp>
+        <p:nvSpPr>
+          <p:cNvPr id="7" name="Rounded Rectangle 6"/>
+          <p:cNvSpPr/>
+          <p:nvPr/>
+        </p:nvSpPr>
+        <p:spPr>
+          <a:xfrm>
+            <a:off x="640080" y="5440680"/>
+            <a:ext cx="10927080" cy="960120"/>
+          </a:xfrm>
+          <a:prstGeom prst="roundRect">
+            <a:avLst>
+              <a:gd name="adj" fmla="val 6000"/>
+            </a:avLst>
+          </a:prstGeom>
+          <a:solidFill>
+            <a:srgbClr val="14213D"/>
+          </a:solidFill>
+          <a:ln>
+            <a:noFill/>
+          </a:ln>
+          <a:effectLst/>
+        </p:spPr>
+        <p:style>
+          <a:lnRef idx="1">
+            <a:schemeClr val="accent1"/>
+          </a:lnRef>
+          <a:fillRef idx="3">
+            <a:schemeClr val="accent1"/>
+          </a:fillRef>
+          <a:effectRef idx="2">
+            <a:schemeClr val="accent1"/>
+          </a:effectRef>
+          <a:fontRef idx="minor">
+            <a:schemeClr val="lt1"/>
+          </a:fontRef>
+        </p:style>
+        <p:txBody>
+          <a:bodyPr rtlCol="0" anchor="ctr"/>
+          <a:lstStyle/>
+          <a:p>
+            <a:pPr algn="ctr"/>
+          </a:p>
+        </p:txBody>
+      </p:sp>
+      <p:sp>
+        <p:nvSpPr>
+          <p:cNvPr id="8" name="TextBox 7"/>
+          <p:cNvSpPr txBox="1"/>
+          <p:nvPr/>
+        </p:nvSpPr>
+        <p:spPr>
+          <a:xfrm>
+            <a:off x="868680" y="5504688"/>
+            <a:ext cx="2377440" cy="868680"/>
+          </a:xfrm>
+          <a:prstGeom prst="rect">
+            <a:avLst/>
+          </a:prstGeom>
+          <a:noFill/>
+        </p:spPr>
+        <p:txBody>
+          <a:bodyPr wrap="square" anchor="ctr" lIns="25400" rIns="25400" tIns="25400" bIns="25400">
+            <a:spAutoFit/>
+          </a:bodyPr>
+          <a:lstStyle/>
+          <a:p>
+            <a:pPr algn="ctr">
+              <a:spcAft>
+                <a:spcPts val="200"/>
+              </a:spcAft>
+            </a:pPr>
+            <a:r>
+              <a:rPr sz="3400" b="1" i="0">
+                <a:solidFill>
+                  <a:srgbClr val="E8871E"/>
+                </a:solidFill>
+                <a:latin typeface="Cambria"/>
+              </a:rPr>
+              <a:t>−7.4%</a:t>
+            </a:r>
+          </a:p>
+        </p:txBody>
+      </p:sp>
+      <p:sp>
+        <p:nvSpPr>
+          <p:cNvPr id="9" name="TextBox 8"/>
+          <p:cNvSpPr txBox="1"/>
+          <p:nvPr/>
+        </p:nvSpPr>
+        <p:spPr>
+          <a:xfrm>
+            <a:off x="3200400" y="5532120"/>
+            <a:ext cx="8229600" cy="868680"/>
+          </a:xfrm>
+          <a:prstGeom prst="rect">
+            <a:avLst/>
+          </a:prstGeom>
+          <a:noFill/>
+        </p:spPr>
+        <p:txBody>
+          <a:bodyPr wrap="square" anchor="ctr" lIns="25400" rIns="25400" tIns="25400" bIns="25400">
+            <a:spAutoFit/>
+          </a:bodyPr>
+          <a:lstStyle/>
+          <a:p>
+            <a:pPr algn="l">
+              <a:lnSpc>
+                <a:spcPct val="112000"/>
+              </a:lnSpc>
+              <a:spcAft>
+                <a:spcPts val="200"/>
+              </a:spcAft>
+            </a:pPr>
+            <a:r>
+              <a:rPr sz="1500" b="1" i="0">
+                <a:solidFill>
+                  <a:srgbClr val="FFFFFF"/>
+                </a:solidFill>
+                <a:latin typeface="Calibri"/>
+              </a:rPr>
+              <a:t>mean BI improvement</a:t>
+            </a:r>
+            <a:r>
+              <a:rPr sz="1500" b="0" i="0">
+                <a:solidFill>
+                  <a:srgbClr val="CADCFC"/>
+                </a:solidFill>
+                <a:latin typeface="Calibri"/>
+              </a:rPr>
+              <a:t> — the Wiener filter lowers the BI on every channel and every bias point. </a:t>
+            </a:r>
+          </a:p>
+          <a:p>
+            <a:pPr algn="l">
+              <a:lnSpc>
+                <a:spcPct val="112000"/>
+              </a:lnSpc>
+              <a:spcBef>
+                <a:spcPts val="300"/>
+              </a:spcBef>
+              <a:spcAft>
+                <a:spcPts val="200"/>
+              </a:spcAft>
+            </a:pPr>
+            <a:r>
+              <a:rPr sz="1400" b="0" i="0">
+                <a:solidFill>
+                  <a:srgbClr val="CADCFC"/>
+                </a:solidFill>
+                <a:latin typeface="Calibri"/>
+              </a:rPr>
+              <a:t>Largest on ch91 (+12.6%), the anomalous detector; up to +27% at individual ch34 working points.</a:t>
             </a:r>
           </a:p>
         </p:txBody>

</xml_diff>